<commit_message>
fix: resolve public release blockers
</commit_message>
<xml_diff>
--- a/docs/midnight-mcp-demo.pptx
+++ b/docs/midnight-mcp-demo.pptx
@@ -2875,7 +2875,7 @@
                   <a:srgbClr val="CCCCCC"/>
                 </a:solidFill>
               </a:rPr>
-              <a:t>witness（非公開）= 金額・送金先</a:t>
+              <a:t>witness入力 = 金額・受取人公開鍵（回路内で公開）</a:t>
             </a:r>
             <a:endParaRPr lang="en-US" sz="1600" dirty="0"/>
           </a:p>
@@ -3036,7 +3036,7 @@
                   <a:srgbClr val="FFFFFF"/>
                 </a:solidFill>
               </a:rPr>
-              <a:t>プライベート決済</a:t>
+              <a:t>秘匿残高更新PoC</a:t>
             </a:r>
             <a:endParaRPr lang="en-US" sz="1500" dirty="0"/>
           </a:p>
@@ -3072,7 +3072,7 @@
                   <a:srgbClr val="CCCCCC"/>
                 </a:solidFill>
               </a:rPr>
-              <a:t>送金額・送金先を非公開に</a:t>
+              <a:t>金額は秘匿・相手公開鍵は公開</a:t>
             </a:r>
             <a:endParaRPr lang="en-US" sz="1200" dirty="0"/>
           </a:p>

</xml_diff>

<commit_message>
Port Midnight Private Payment Demo v2 to the current stack (#1)
Port the workshop demo to the current Midnight stack, add progress-aware Demo wallet synchronization, visibility and policy panels, public-release hardening, and fail-closed Preprod preflight tooling.
</commit_message>
<xml_diff>
--- a/docs/midnight-mcp-demo.pptx
+++ b/docs/midnight-mcp-demo.pptx
@@ -2875,7 +2875,7 @@
                   <a:srgbClr val="CCCCCC"/>
                 </a:solidFill>
               </a:rPr>
-              <a:t>witness（非公開）= 金額・送金先</a:t>
+              <a:t>witness入力 = 金額・受取人公開鍵（回路内で公開）</a:t>
             </a:r>
             <a:endParaRPr lang="en-US" sz="1600" dirty="0"/>
           </a:p>
@@ -3036,7 +3036,7 @@
                   <a:srgbClr val="FFFFFF"/>
                 </a:solidFill>
               </a:rPr>
-              <a:t>プライベート決済</a:t>
+              <a:t>秘匿残高更新PoC</a:t>
             </a:r>
             <a:endParaRPr lang="en-US" sz="1500" dirty="0"/>
           </a:p>
@@ -3072,7 +3072,7 @@
                   <a:srgbClr val="CCCCCC"/>
                 </a:solidFill>
               </a:rPr>
-              <a:t>送金額・送金先を非公開に</a:t>
+              <a:t>金額は秘匿・相手公開鍵は公開</a:t>
             </a:r>
             <a:endParaRPr lang="en-US" sz="1200" dirty="0"/>
           </a:p>

</xml_diff>